<commit_message>
feat: remove practice archive and update navigation, routes, and docs
</commit_message>
<xml_diff>
--- a/TechnoWallah_Executive_Presentation.pptx
+++ b/TechnoWallah_Executive_Presentation.pptx
@@ -4712,7 +4712,7 @@
               </a:defRPr>
             </a:pPr>
             <a:r>
-              <a:t>INPUT SCREEN 4: Practice &amp; Self-Evaluation Controls (`/practice`)</a:t>
+              <a:t>INPUT SCREEN 4: Platforms Directory Filter Controls (`/platforms`)</a:t>
             </a:r>
           </a:p>
           <a:p>
@@ -4727,7 +4727,7 @@
               </a:defRPr>
             </a:pPr>
             <a:r>
-              <a:t>• Examination Filter Selector: Switch practice sessions between UPSC CSE, GRE, GMAT, and CLAT question banks</a:t>
+              <a:t>• Institutional Search Bar: Keyword search query across platform names, organizations (IITs, MIT, NCERT), and subjects</a:t>
             </a:r>
           </a:p>
           <a:p>
@@ -4742,7 +4742,7 @@
               </a:defRPr>
             </a:pPr>
             <a:r>
-              <a:t>• Interactive Option Inputs (A/B/C/D): Touch-friendly option selection buttons capturing user choice instantaneously</a:t>
+              <a:t>• Platform Category Selector: Dropdown selection for University Video Lectures, Global OCW, Open Textbooks, and Digital Archives</a:t>
             </a:r>
           </a:p>
           <a:p>
@@ -4757,7 +4757,7 @@
               </a:defRPr>
             </a:pPr>
             <a:r>
-              <a:t>• State Management: React state tracks user answers per question ID without requiring page reloads</a:t>
+              <a:t>• Domain Quick Filters: Interactive tag filters for Engineering, Humanities, Science, Law, and Public Administration</a:t>
             </a:r>
           </a:p>
           <a:p>
@@ -4772,7 +4772,7 @@
               </a:defRPr>
             </a:pPr>
             <a:r>
-              <a:t>• Reset Session Button: Circular reset action allowing students to clear evaluation states and restart review</a:t>
+              <a:t>• Live Filter Evaluation: Instant client-side re-indexing without server roundtrips or page reload delays</a:t>
             </a:r>
           </a:p>
           <a:p>
@@ -4787,7 +4787,7 @@
               </a:defRPr>
             </a:pPr>
             <a:r>
-              <a:t>• Free-Form Question Search: Query input filtering questions by subject, concept, or historical exam year</a:t>
+              <a:t>• Platform URL Redirection: One-tap outbound direct link to verified institutional portals</a:t>
             </a:r>
           </a:p>
         </p:txBody>
@@ -4893,7 +4893,7 @@
               </a:defRPr>
             </a:pPr>
             <a:r>
-              <a:t>Syllabus Roadmaps, Verified PYQ Analytics &amp; Real-Time Scorecards</a:t>
+              <a:t>Syllabus Roadmaps &amp; Institutional Learning Platform Profiles</a:t>
             </a:r>
           </a:p>
         </p:txBody>
@@ -5082,7 +5082,7 @@
               </a:defRPr>
             </a:pPr>
             <a:r>
-              <a:t>OUTPUT REPORT 2: Evaluation Scorecard &amp; Solution Analysis (`/practice`)</a:t>
+              <a:t>OUTPUT REPORT 2: Learning Platforms Accreditation Directory (`/platforms`)</a:t>
             </a:r>
           </a:p>
           <a:p>
@@ -5097,7 +5097,7 @@
               </a:defRPr>
             </a:pPr>
             <a:r>
-              <a:t>• Real-Time KPI Metric Bar: Instant scoreboard showing 'Total Reviewed' and 'Total Correct' with accuracy analytics</a:t>
+              <a:t>• Institutional Platform Profiles: Comprehensive dossiers on NPTEL, MIT OCW, NCERT, OpenStax, IGNOU, and NDLI</a:t>
             </a:r>
           </a:p>
           <a:p>
@@ -5112,7 +5112,7 @@
               </a:defRPr>
             </a:pPr>
             <a:r>
-              <a:t>• Dynamic Visual Feedback: Selected options immediately highlight in Emerald Green (Correct) or Crimson Red (Incorrect)</a:t>
+              <a:t>• Accreditation &amp; Governance Model: Verifies state-funded, university-backed, and non-profit public OER licensing</a:t>
             </a:r>
           </a:p>
           <a:p>
@@ -5127,7 +5127,7 @@
               </a:defRPr>
             </a:pPr>
             <a:r>
-              <a:t>• Step-by-Step Solution Report: Instant reveal of comprehensive pedagogical explanations upon answering</a:t>
+              <a:t>• Discipline Coverage Tag Cloud: Categorized coverage across Engineering, Humanities, Pure Sciences, Law, and Public Administration</a:t>
             </a:r>
           </a:p>
           <a:p>
@@ -5142,7 +5142,7 @@
               </a:defRPr>
             </a:pPr>
             <a:r>
-              <a:t>• Source Attribution: Direct citation of question origin (e.g., 'UPSC CSE Prelims Paper I' or 'GRE ETS Official')</a:t>
+              <a:t>• Direct Primary Portal Gateway: One-click external launch directly into the primary verified learning platform</a:t>
             </a:r>
           </a:p>
           <a:p>
@@ -5157,7 +5157,7 @@
               </a:defRPr>
             </a:pPr>
             <a:r>
-              <a:t>• Textbook Cross-Reference: Recommends exact open textbook chapters to revise if the student answers incorrectly</a:t>
+              <a:t>• Zero Subscription Guarantee: Explicit verification badge confirming 100% Free Open Educational Resource status</a:t>
             </a:r>
           </a:p>
         </p:txBody>
@@ -6901,7 +6901,7 @@
               </a:defRPr>
             </a:pPr>
             <a:r>
-              <a:t>• Fixed Mobile Nav Dock: 1-tap thumb navigation between Home, Exams, Library, Platforms, and Practice.</a:t>
+              <a:t>• Fixed Mobile Nav Dock: 1-tap thumb navigation between Home, Exams, Library, and Platforms.</a:t>
             </a:r>
           </a:p>
           <a:p>

</xml_diff>